<commit_message>
Update Topic 6 - Artificial Neural Networks.pptx
</commit_message>
<xml_diff>
--- a/Course content/Slides/Topic 6 - Artificial Neural Networks.pptx
+++ b/Course content/Slides/Topic 6 - Artificial Neural Networks.pptx
@@ -227,7 +227,7 @@
           <a:p>
             <a:fld id="{B9B1DC7F-8587-4047-9A5D-1FCB6614CAE0}" type="datetimeFigureOut">
               <a:rPr lang="en-US" smtClean="0"/>
-              <a:t>11/25/2022</a:t>
+              <a:t>11/28/2022</a:t>
             </a:fld>
             <a:endParaRPr lang="en-US"/>
           </a:p>
@@ -641,7 +641,7 @@
           <a:p>
             <a:fld id="{A7DB5662-7327-465C-9A70-AD96B7A8D67A}" type="datetimeFigureOut">
               <a:rPr lang="en-US" smtClean="0"/>
-              <a:t>11/25/2022</a:t>
+              <a:t>11/28/2022</a:t>
             </a:fld>
             <a:endParaRPr lang="en-US"/>
           </a:p>
@@ -839,7 +839,7 @@
           <a:p>
             <a:fld id="{A7DB5662-7327-465C-9A70-AD96B7A8D67A}" type="datetimeFigureOut">
               <a:rPr lang="en-US" smtClean="0"/>
-              <a:t>11/25/2022</a:t>
+              <a:t>11/28/2022</a:t>
             </a:fld>
             <a:endParaRPr lang="en-US"/>
           </a:p>
@@ -1047,7 +1047,7 @@
           <a:p>
             <a:fld id="{A7DB5662-7327-465C-9A70-AD96B7A8D67A}" type="datetimeFigureOut">
               <a:rPr lang="en-US" smtClean="0"/>
-              <a:t>11/25/2022</a:t>
+              <a:t>11/28/2022</a:t>
             </a:fld>
             <a:endParaRPr lang="en-US"/>
           </a:p>
@@ -1245,7 +1245,7 @@
           <a:p>
             <a:fld id="{A7DB5662-7327-465C-9A70-AD96B7A8D67A}" type="datetimeFigureOut">
               <a:rPr lang="en-US" smtClean="0"/>
-              <a:t>11/25/2022</a:t>
+              <a:t>11/28/2022</a:t>
             </a:fld>
             <a:endParaRPr lang="en-US"/>
           </a:p>
@@ -1520,7 +1520,7 @@
           <a:p>
             <a:fld id="{A7DB5662-7327-465C-9A70-AD96B7A8D67A}" type="datetimeFigureOut">
               <a:rPr lang="en-US" smtClean="0"/>
-              <a:t>11/25/2022</a:t>
+              <a:t>11/28/2022</a:t>
             </a:fld>
             <a:endParaRPr lang="en-US"/>
           </a:p>
@@ -1785,7 +1785,7 @@
           <a:p>
             <a:fld id="{A7DB5662-7327-465C-9A70-AD96B7A8D67A}" type="datetimeFigureOut">
               <a:rPr lang="en-US" smtClean="0"/>
-              <a:t>11/25/2022</a:t>
+              <a:t>11/28/2022</a:t>
             </a:fld>
             <a:endParaRPr lang="en-US"/>
           </a:p>
@@ -2197,7 +2197,7 @@
           <a:p>
             <a:fld id="{A7DB5662-7327-465C-9A70-AD96B7A8D67A}" type="datetimeFigureOut">
               <a:rPr lang="en-US" smtClean="0"/>
-              <a:t>11/25/2022</a:t>
+              <a:t>11/28/2022</a:t>
             </a:fld>
             <a:endParaRPr lang="en-US"/>
           </a:p>
@@ -2338,7 +2338,7 @@
           <a:p>
             <a:fld id="{A7DB5662-7327-465C-9A70-AD96B7A8D67A}" type="datetimeFigureOut">
               <a:rPr lang="en-US" smtClean="0"/>
-              <a:t>11/25/2022</a:t>
+              <a:t>11/28/2022</a:t>
             </a:fld>
             <a:endParaRPr lang="en-US"/>
           </a:p>
@@ -2451,7 +2451,7 @@
           <a:p>
             <a:fld id="{A7DB5662-7327-465C-9A70-AD96B7A8D67A}" type="datetimeFigureOut">
               <a:rPr lang="en-US" smtClean="0"/>
-              <a:t>11/25/2022</a:t>
+              <a:t>11/28/2022</a:t>
             </a:fld>
             <a:endParaRPr lang="en-US"/>
           </a:p>
@@ -2762,7 +2762,7 @@
           <a:p>
             <a:fld id="{A7DB5662-7327-465C-9A70-AD96B7A8D67A}" type="datetimeFigureOut">
               <a:rPr lang="en-US" smtClean="0"/>
-              <a:t>11/25/2022</a:t>
+              <a:t>11/28/2022</a:t>
             </a:fld>
             <a:endParaRPr lang="en-US"/>
           </a:p>
@@ -3050,7 +3050,7 @@
           <a:p>
             <a:fld id="{A7DB5662-7327-465C-9A70-AD96B7A8D67A}" type="datetimeFigureOut">
               <a:rPr lang="en-US" smtClean="0"/>
-              <a:t>11/25/2022</a:t>
+              <a:t>11/28/2022</a:t>
             </a:fld>
             <a:endParaRPr lang="en-US"/>
           </a:p>
@@ -3291,7 +3291,7 @@
           <a:p>
             <a:fld id="{A7DB5662-7327-465C-9A70-AD96B7A8D67A}" type="datetimeFigureOut">
               <a:rPr lang="en-US" smtClean="0"/>
-              <a:t>11/25/2022</a:t>
+              <a:t>11/28/2022</a:t>
             </a:fld>
             <a:endParaRPr lang="en-US"/>
           </a:p>
@@ -26295,10 +26295,10 @@
       </p:pic>
       <p:grpSp>
         <p:nvGrpSpPr>
-          <p:cNvPr id="17" name="Group 16">
+          <p:cNvPr id="20" name="Group 19">
             <a:extLst>
               <a:ext uri="{FF2B5EF4-FFF2-40B4-BE49-F238E27FC236}">
-                <a16:creationId xmlns:a16="http://schemas.microsoft.com/office/drawing/2014/main" id="{09DA4226-2B79-BB9C-641A-9010BDB07B17}"/>
+                <a16:creationId xmlns:a16="http://schemas.microsoft.com/office/drawing/2014/main" id="{2CA3778D-231D-C062-7613-41E91CAD379E}"/>
               </a:ext>
             </a:extLst>
           </p:cNvPr>
@@ -26307,209 +26307,448 @@
         </p:nvGrpSpPr>
         <p:grpSpPr>
           <a:xfrm>
-            <a:off x="1486384" y="3918872"/>
-            <a:ext cx="2519872" cy="2384308"/>
-            <a:chOff x="1486384" y="3918872"/>
-            <a:chExt cx="2519872" cy="2384308"/>
+            <a:off x="1486384" y="4059790"/>
+            <a:ext cx="2519872" cy="2225370"/>
+            <a:chOff x="1486384" y="4395291"/>
+            <a:chExt cx="2519872" cy="2225370"/>
           </a:xfrm>
         </p:grpSpPr>
-        <p:pic>
-          <p:nvPicPr>
-            <p:cNvPr id="13" name="Picture 12" descr="Diagram&#10;&#10;Description automatically generated">
+        <p:grpSp>
+          <p:nvGrpSpPr>
+            <p:cNvPr id="17" name="Group 16">
               <a:extLst>
                 <a:ext uri="{FF2B5EF4-FFF2-40B4-BE49-F238E27FC236}">
-                  <a16:creationId xmlns:a16="http://schemas.microsoft.com/office/drawing/2014/main" id="{161B374F-A475-E984-A1EA-710DEFF19672}"/>
+                  <a16:creationId xmlns:a16="http://schemas.microsoft.com/office/drawing/2014/main" id="{09DA4226-2B79-BB9C-641A-9010BDB07B17}"/>
                 </a:ext>
               </a:extLst>
             </p:cNvPr>
-            <p:cNvPicPr>
-              <a:picLocks noChangeAspect="1"/>
-            </p:cNvPicPr>
+            <p:cNvGrpSpPr/>
             <p:nvPr/>
-          </p:nvPicPr>
-          <p:blipFill rotWithShape="1">
-            <a:blip r:embed="rId4">
-              <a:extLst>
-                <a:ext uri="{28A0092B-C50C-407E-A947-70E740481C1C}">
-                  <a14:useLocalDpi xmlns:a14="http://schemas.microsoft.com/office/drawing/2010/main" val="0"/>
-                </a:ext>
-              </a:extLst>
-            </a:blip>
-            <a:srcRect r="14060"/>
-            <a:stretch/>
-          </p:blipFill>
-          <p:spPr>
+          </p:nvGrpSpPr>
+          <p:grpSpPr>
             <a:xfrm>
-              <a:off x="1742997" y="3918872"/>
-              <a:ext cx="2263259" cy="2384308"/>
+              <a:off x="1486384" y="4547728"/>
+              <a:ext cx="2519872" cy="1755451"/>
+              <a:chOff x="1486384" y="4547728"/>
+              <a:chExt cx="2519872" cy="1755451"/>
             </a:xfrm>
-            <a:prstGeom prst="rect">
-              <a:avLst/>
-            </a:prstGeom>
-          </p:spPr>
-        </p:pic>
-        <p:sp>
-          <p:nvSpPr>
-            <p:cNvPr id="14" name="Rectangle 13">
+          </p:grpSpPr>
+          <p:pic>
+            <p:nvPicPr>
+              <p:cNvPr id="13" name="Picture 12" descr="Diagram&#10;&#10;Description automatically generated">
+                <a:extLst>
+                  <a:ext uri="{FF2B5EF4-FFF2-40B4-BE49-F238E27FC236}">
+                    <a16:creationId xmlns:a16="http://schemas.microsoft.com/office/drawing/2014/main" id="{161B374F-A475-E984-A1EA-710DEFF19672}"/>
+                  </a:ext>
+                </a:extLst>
+              </p:cNvPr>
+              <p:cNvPicPr>
+                <a:picLocks noChangeAspect="1"/>
+              </p:cNvPicPr>
+              <p:nvPr/>
+            </p:nvPicPr>
+            <p:blipFill rotWithShape="1">
+              <a:blip r:embed="rId4">
+                <a:extLst>
+                  <a:ext uri="{28A0092B-C50C-407E-A947-70E740481C1C}">
+                    <a14:useLocalDpi xmlns:a14="http://schemas.microsoft.com/office/drawing/2010/main" val="0"/>
+                  </a:ext>
+                </a:extLst>
+              </a:blip>
+              <a:srcRect t="26375" r="14060"/>
+              <a:stretch/>
+            </p:blipFill>
+            <p:spPr>
+              <a:xfrm>
+                <a:off x="1742997" y="4547728"/>
+                <a:ext cx="2263259" cy="1755451"/>
+              </a:xfrm>
+              <a:prstGeom prst="rect">
+                <a:avLst/>
+              </a:prstGeom>
+            </p:spPr>
+          </p:pic>
+          <p:sp>
+            <p:nvSpPr>
+              <p:cNvPr id="14" name="Rectangle 13">
+                <a:extLst>
+                  <a:ext uri="{FF2B5EF4-FFF2-40B4-BE49-F238E27FC236}">
+                    <a16:creationId xmlns:a16="http://schemas.microsoft.com/office/drawing/2014/main" id="{8C001A13-B3B4-E743-5B7E-16AF007BA583}"/>
+                  </a:ext>
+                </a:extLst>
+              </p:cNvPr>
+              <p:cNvSpPr/>
+              <p:nvPr/>
+            </p:nvSpPr>
+            <p:spPr>
+              <a:xfrm>
+                <a:off x="2108217" y="4885643"/>
+                <a:ext cx="987100" cy="174415"/>
+              </a:xfrm>
+              <a:prstGeom prst="rect">
+                <a:avLst/>
+              </a:prstGeom>
+              <a:solidFill>
+                <a:schemeClr val="bg1"/>
+              </a:solidFill>
+              <a:ln>
+                <a:solidFill>
+                  <a:schemeClr val="bg1"/>
+                </a:solidFill>
+              </a:ln>
+            </p:spPr>
+            <p:style>
+              <a:lnRef idx="2">
+                <a:schemeClr val="accent1">
+                  <a:shade val="50000"/>
+                </a:schemeClr>
+              </a:lnRef>
+              <a:fillRef idx="1">
+                <a:schemeClr val="accent1"/>
+              </a:fillRef>
+              <a:effectRef idx="0">
+                <a:schemeClr val="accent1"/>
+              </a:effectRef>
+              <a:fontRef idx="minor">
+                <a:schemeClr val="lt1"/>
+              </a:fontRef>
+            </p:style>
+            <p:txBody>
+              <a:bodyPr rtlCol="0" anchor="ctr"/>
+              <a:lstStyle/>
+              <a:p>
+                <a:pPr algn="ctr"/>
+                <a:endParaRPr lang="en-US"/>
+              </a:p>
+            </p:txBody>
+          </p:sp>
+          <p:sp>
+            <p:nvSpPr>
+              <p:cNvPr id="15" name="Rectangle 14">
+                <a:extLst>
+                  <a:ext uri="{FF2B5EF4-FFF2-40B4-BE49-F238E27FC236}">
+                    <a16:creationId xmlns:a16="http://schemas.microsoft.com/office/drawing/2014/main" id="{75BB7823-412D-FAB2-3B63-E2894EB5FB02}"/>
+                  </a:ext>
+                </a:extLst>
+              </p:cNvPr>
+              <p:cNvSpPr/>
+              <p:nvPr/>
+            </p:nvSpPr>
+            <p:spPr>
+              <a:xfrm>
+                <a:off x="1657761" y="4743039"/>
+                <a:ext cx="763097" cy="1401203"/>
+              </a:xfrm>
+              <a:prstGeom prst="rect">
+                <a:avLst/>
+              </a:prstGeom>
+              <a:solidFill>
+                <a:schemeClr val="bg1"/>
+              </a:solidFill>
+              <a:ln>
+                <a:solidFill>
+                  <a:schemeClr val="bg1"/>
+                </a:solidFill>
+              </a:ln>
+            </p:spPr>
+            <p:style>
+              <a:lnRef idx="2">
+                <a:schemeClr val="accent1">
+                  <a:shade val="50000"/>
+                </a:schemeClr>
+              </a:lnRef>
+              <a:fillRef idx="1">
+                <a:schemeClr val="accent1"/>
+              </a:fillRef>
+              <a:effectRef idx="0">
+                <a:schemeClr val="accent1"/>
+              </a:effectRef>
+              <a:fontRef idx="minor">
+                <a:schemeClr val="lt1"/>
+              </a:fontRef>
+            </p:style>
+            <p:txBody>
+              <a:bodyPr rtlCol="0" anchor="ctr"/>
+              <a:lstStyle/>
+              <a:p>
+                <a:pPr algn="ctr"/>
+                <a:endParaRPr lang="en-US"/>
+              </a:p>
+            </p:txBody>
+          </p:sp>
+          <p:sp>
+            <p:nvSpPr>
+              <p:cNvPr id="16" name="Rectangle 15">
+                <a:extLst>
+                  <a:ext uri="{FF2B5EF4-FFF2-40B4-BE49-F238E27FC236}">
+                    <a16:creationId xmlns:a16="http://schemas.microsoft.com/office/drawing/2014/main" id="{A25C1B77-60DD-21B2-88DE-8D33EEC8237B}"/>
+                  </a:ext>
+                </a:extLst>
+              </p:cNvPr>
+              <p:cNvSpPr/>
+              <p:nvPr/>
+            </p:nvSpPr>
+            <p:spPr>
+              <a:xfrm>
+                <a:off x="1486384" y="5855361"/>
+                <a:ext cx="1605471" cy="157037"/>
+              </a:xfrm>
+              <a:prstGeom prst="rect">
+                <a:avLst/>
+              </a:prstGeom>
+              <a:solidFill>
+                <a:schemeClr val="bg1"/>
+              </a:solidFill>
+              <a:ln>
+                <a:solidFill>
+                  <a:schemeClr val="bg1"/>
+                </a:solidFill>
+              </a:ln>
+            </p:spPr>
+            <p:style>
+              <a:lnRef idx="2">
+                <a:schemeClr val="accent1">
+                  <a:shade val="50000"/>
+                </a:schemeClr>
+              </a:lnRef>
+              <a:fillRef idx="1">
+                <a:schemeClr val="accent1"/>
+              </a:fillRef>
+              <a:effectRef idx="0">
+                <a:schemeClr val="accent1"/>
+              </a:effectRef>
+              <a:fontRef idx="minor">
+                <a:schemeClr val="lt1"/>
+              </a:fontRef>
+            </p:style>
+            <p:txBody>
+              <a:bodyPr rtlCol="0" anchor="ctr"/>
+              <a:lstStyle/>
+              <a:p>
+                <a:pPr algn="ctr"/>
+                <a:endParaRPr lang="en-US"/>
+              </a:p>
+            </p:txBody>
+          </p:sp>
+        </p:grpSp>
+        <p:grpSp>
+          <p:nvGrpSpPr>
+            <p:cNvPr id="5" name="Group 4">
               <a:extLst>
                 <a:ext uri="{FF2B5EF4-FFF2-40B4-BE49-F238E27FC236}">
-                  <a16:creationId xmlns:a16="http://schemas.microsoft.com/office/drawing/2014/main" id="{8C001A13-B3B4-E743-5B7E-16AF007BA583}"/>
+                  <a16:creationId xmlns:a16="http://schemas.microsoft.com/office/drawing/2014/main" id="{26035D5B-B74D-0274-BCF6-55007CAAC3CF}"/>
                 </a:ext>
               </a:extLst>
             </p:cNvPr>
-            <p:cNvSpPr/>
+            <p:cNvGrpSpPr/>
             <p:nvPr/>
-          </p:nvSpPr>
-          <p:spPr>
+          </p:nvGrpSpPr>
+          <p:grpSpPr>
             <a:xfrm>
-              <a:off x="2108217" y="4885643"/>
-              <a:ext cx="987100" cy="174415"/>
+              <a:off x="1486384" y="4395291"/>
+              <a:ext cx="2519872" cy="2225370"/>
+              <a:chOff x="1486384" y="3918872"/>
+              <a:chExt cx="2519872" cy="2225370"/>
             </a:xfrm>
-            <a:prstGeom prst="rect">
-              <a:avLst/>
-            </a:prstGeom>
-            <a:solidFill>
-              <a:schemeClr val="bg1"/>
-            </a:solidFill>
-            <a:ln>
+          </p:grpSpPr>
+          <p:pic>
+            <p:nvPicPr>
+              <p:cNvPr id="7" name="Picture 6" descr="Diagram&#10;&#10;Description automatically generated">
+                <a:extLst>
+                  <a:ext uri="{FF2B5EF4-FFF2-40B4-BE49-F238E27FC236}">
+                    <a16:creationId xmlns:a16="http://schemas.microsoft.com/office/drawing/2014/main" id="{1210681E-6473-479D-DB70-0765899913A7}"/>
+                  </a:ext>
+                </a:extLst>
+              </p:cNvPr>
+              <p:cNvPicPr>
+                <a:picLocks noChangeAspect="1"/>
+              </p:cNvPicPr>
+              <p:nvPr/>
+            </p:nvPicPr>
+            <p:blipFill rotWithShape="1">
+              <a:blip r:embed="rId4">
+                <a:extLst>
+                  <a:ext uri="{28A0092B-C50C-407E-A947-70E740481C1C}">
+                    <a14:useLocalDpi xmlns:a14="http://schemas.microsoft.com/office/drawing/2010/main" val="0"/>
+                  </a:ext>
+                </a:extLst>
+              </a:blip>
+              <a:srcRect r="14060" b="74845"/>
+              <a:stretch/>
+            </p:blipFill>
+            <p:spPr>
+              <a:xfrm>
+                <a:off x="1742997" y="3918872"/>
+                <a:ext cx="2263259" cy="599770"/>
+              </a:xfrm>
+              <a:prstGeom prst="rect">
+                <a:avLst/>
+              </a:prstGeom>
+            </p:spPr>
+          </p:pic>
+          <p:sp>
+            <p:nvSpPr>
+              <p:cNvPr id="8" name="Rectangle 7">
+                <a:extLst>
+                  <a:ext uri="{FF2B5EF4-FFF2-40B4-BE49-F238E27FC236}">
+                    <a16:creationId xmlns:a16="http://schemas.microsoft.com/office/drawing/2014/main" id="{16A748CA-326E-13EE-8B0E-14C6E5A9DFA7}"/>
+                  </a:ext>
+                </a:extLst>
+              </p:cNvPr>
+              <p:cNvSpPr/>
+              <p:nvPr/>
+            </p:nvSpPr>
+            <p:spPr>
+              <a:xfrm>
+                <a:off x="2108217" y="4885643"/>
+                <a:ext cx="987100" cy="174415"/>
+              </a:xfrm>
+              <a:prstGeom prst="rect">
+                <a:avLst/>
+              </a:prstGeom>
               <a:solidFill>
                 <a:schemeClr val="bg1"/>
               </a:solidFill>
-            </a:ln>
-          </p:spPr>
-          <p:style>
-            <a:lnRef idx="2">
-              <a:schemeClr val="accent1">
-                <a:shade val="50000"/>
-              </a:schemeClr>
-            </a:lnRef>
-            <a:fillRef idx="1">
-              <a:schemeClr val="accent1"/>
-            </a:fillRef>
-            <a:effectRef idx="0">
-              <a:schemeClr val="accent1"/>
-            </a:effectRef>
-            <a:fontRef idx="minor">
-              <a:schemeClr val="lt1"/>
-            </a:fontRef>
-          </p:style>
-          <p:txBody>
-            <a:bodyPr rtlCol="0" anchor="ctr"/>
-            <a:lstStyle/>
-            <a:p>
-              <a:pPr algn="ctr"/>
-              <a:endParaRPr lang="en-US"/>
-            </a:p>
-          </p:txBody>
-        </p:sp>
-        <p:sp>
-          <p:nvSpPr>
-            <p:cNvPr id="15" name="Rectangle 14">
-              <a:extLst>
-                <a:ext uri="{FF2B5EF4-FFF2-40B4-BE49-F238E27FC236}">
-                  <a16:creationId xmlns:a16="http://schemas.microsoft.com/office/drawing/2014/main" id="{75BB7823-412D-FAB2-3B63-E2894EB5FB02}"/>
-                </a:ext>
-              </a:extLst>
-            </p:cNvPr>
-            <p:cNvSpPr/>
-            <p:nvPr/>
-          </p:nvSpPr>
-          <p:spPr>
-            <a:xfrm>
-              <a:off x="1657761" y="4743039"/>
-              <a:ext cx="763097" cy="1401203"/>
-            </a:xfrm>
-            <a:prstGeom prst="rect">
-              <a:avLst/>
-            </a:prstGeom>
-            <a:solidFill>
-              <a:schemeClr val="bg1"/>
-            </a:solidFill>
-            <a:ln>
+              <a:ln>
+                <a:solidFill>
+                  <a:schemeClr val="bg1"/>
+                </a:solidFill>
+              </a:ln>
+            </p:spPr>
+            <p:style>
+              <a:lnRef idx="2">
+                <a:schemeClr val="accent1">
+                  <a:shade val="50000"/>
+                </a:schemeClr>
+              </a:lnRef>
+              <a:fillRef idx="1">
+                <a:schemeClr val="accent1"/>
+              </a:fillRef>
+              <a:effectRef idx="0">
+                <a:schemeClr val="accent1"/>
+              </a:effectRef>
+              <a:fontRef idx="minor">
+                <a:schemeClr val="lt1"/>
+              </a:fontRef>
+            </p:style>
+            <p:txBody>
+              <a:bodyPr rtlCol="0" anchor="ctr"/>
+              <a:lstStyle/>
+              <a:p>
+                <a:pPr algn="ctr"/>
+                <a:endParaRPr lang="en-US"/>
+              </a:p>
+            </p:txBody>
+          </p:sp>
+          <p:sp>
+            <p:nvSpPr>
+              <p:cNvPr id="18" name="Rectangle 17">
+                <a:extLst>
+                  <a:ext uri="{FF2B5EF4-FFF2-40B4-BE49-F238E27FC236}">
+                    <a16:creationId xmlns:a16="http://schemas.microsoft.com/office/drawing/2014/main" id="{ED16E7D8-3D8C-9348-BEFA-5A330D874CB4}"/>
+                  </a:ext>
+                </a:extLst>
+              </p:cNvPr>
+              <p:cNvSpPr/>
+              <p:nvPr/>
+            </p:nvSpPr>
+            <p:spPr>
+              <a:xfrm>
+                <a:off x="1677495" y="4743039"/>
+                <a:ext cx="763097" cy="1401203"/>
+              </a:xfrm>
+              <a:prstGeom prst="rect">
+                <a:avLst/>
+              </a:prstGeom>
               <a:solidFill>
                 <a:schemeClr val="bg1"/>
               </a:solidFill>
-            </a:ln>
-          </p:spPr>
-          <p:style>
-            <a:lnRef idx="2">
-              <a:schemeClr val="accent1">
-                <a:shade val="50000"/>
-              </a:schemeClr>
-            </a:lnRef>
-            <a:fillRef idx="1">
-              <a:schemeClr val="accent1"/>
-            </a:fillRef>
-            <a:effectRef idx="0">
-              <a:schemeClr val="accent1"/>
-            </a:effectRef>
-            <a:fontRef idx="minor">
-              <a:schemeClr val="lt1"/>
-            </a:fontRef>
-          </p:style>
-          <p:txBody>
-            <a:bodyPr rtlCol="0" anchor="ctr"/>
-            <a:lstStyle/>
-            <a:p>
-              <a:pPr algn="ctr"/>
-              <a:endParaRPr lang="en-US"/>
-            </a:p>
-          </p:txBody>
-        </p:sp>
-        <p:sp>
-          <p:nvSpPr>
-            <p:cNvPr id="16" name="Rectangle 15">
-              <a:extLst>
-                <a:ext uri="{FF2B5EF4-FFF2-40B4-BE49-F238E27FC236}">
-                  <a16:creationId xmlns:a16="http://schemas.microsoft.com/office/drawing/2014/main" id="{A25C1B77-60DD-21B2-88DE-8D33EEC8237B}"/>
-                </a:ext>
-              </a:extLst>
-            </p:cNvPr>
-            <p:cNvSpPr/>
-            <p:nvPr/>
-          </p:nvSpPr>
-          <p:spPr>
-            <a:xfrm>
-              <a:off x="1486384" y="5855361"/>
-              <a:ext cx="1605471" cy="157037"/>
-            </a:xfrm>
-            <a:prstGeom prst="rect">
-              <a:avLst/>
-            </a:prstGeom>
-            <a:solidFill>
-              <a:schemeClr val="bg1"/>
-            </a:solidFill>
-            <a:ln>
+              <a:ln>
+                <a:solidFill>
+                  <a:schemeClr val="bg1"/>
+                </a:solidFill>
+              </a:ln>
+            </p:spPr>
+            <p:style>
+              <a:lnRef idx="2">
+                <a:schemeClr val="accent1">
+                  <a:shade val="50000"/>
+                </a:schemeClr>
+              </a:lnRef>
+              <a:fillRef idx="1">
+                <a:schemeClr val="accent1"/>
+              </a:fillRef>
+              <a:effectRef idx="0">
+                <a:schemeClr val="accent1"/>
+              </a:effectRef>
+              <a:fontRef idx="minor">
+                <a:schemeClr val="lt1"/>
+              </a:fontRef>
+            </p:style>
+            <p:txBody>
+              <a:bodyPr rtlCol="0" anchor="ctr"/>
+              <a:lstStyle/>
+              <a:p>
+                <a:pPr algn="ctr"/>
+                <a:endParaRPr lang="en-US" dirty="0"/>
+              </a:p>
+            </p:txBody>
+          </p:sp>
+          <p:sp>
+            <p:nvSpPr>
+              <p:cNvPr id="19" name="Rectangle 18">
+                <a:extLst>
+                  <a:ext uri="{FF2B5EF4-FFF2-40B4-BE49-F238E27FC236}">
+                    <a16:creationId xmlns:a16="http://schemas.microsoft.com/office/drawing/2014/main" id="{C3B14EE8-0A1B-2A2B-A7F3-C8DDA7A28D9E}"/>
+                  </a:ext>
+                </a:extLst>
+              </p:cNvPr>
+              <p:cNvSpPr/>
+              <p:nvPr/>
+            </p:nvSpPr>
+            <p:spPr>
+              <a:xfrm>
+                <a:off x="1486384" y="5855361"/>
+                <a:ext cx="1605471" cy="157037"/>
+              </a:xfrm>
+              <a:prstGeom prst="rect">
+                <a:avLst/>
+              </a:prstGeom>
               <a:solidFill>
                 <a:schemeClr val="bg1"/>
               </a:solidFill>
-            </a:ln>
-          </p:spPr>
-          <p:style>
-            <a:lnRef idx="2">
-              <a:schemeClr val="accent1">
-                <a:shade val="50000"/>
-              </a:schemeClr>
-            </a:lnRef>
-            <a:fillRef idx="1">
-              <a:schemeClr val="accent1"/>
-            </a:fillRef>
-            <a:effectRef idx="0">
-              <a:schemeClr val="accent1"/>
-            </a:effectRef>
-            <a:fontRef idx="minor">
-              <a:schemeClr val="lt1"/>
-            </a:fontRef>
-          </p:style>
-          <p:txBody>
-            <a:bodyPr rtlCol="0" anchor="ctr"/>
-            <a:lstStyle/>
-            <a:p>
-              <a:pPr algn="ctr"/>
-              <a:endParaRPr lang="en-US"/>
-            </a:p>
-          </p:txBody>
-        </p:sp>
+              <a:ln>
+                <a:solidFill>
+                  <a:schemeClr val="bg1"/>
+                </a:solidFill>
+              </a:ln>
+            </p:spPr>
+            <p:style>
+              <a:lnRef idx="2">
+                <a:schemeClr val="accent1">
+                  <a:shade val="50000"/>
+                </a:schemeClr>
+              </a:lnRef>
+              <a:fillRef idx="1">
+                <a:schemeClr val="accent1"/>
+              </a:fillRef>
+              <a:effectRef idx="0">
+                <a:schemeClr val="accent1"/>
+              </a:effectRef>
+              <a:fontRef idx="minor">
+                <a:schemeClr val="lt1"/>
+              </a:fontRef>
+            </p:style>
+            <p:txBody>
+              <a:bodyPr rtlCol="0" anchor="ctr"/>
+              <a:lstStyle/>
+              <a:p>
+                <a:pPr algn="ctr"/>
+                <a:endParaRPr lang="en-US"/>
+              </a:p>
+            </p:txBody>
+          </p:sp>
+        </p:grpSp>
       </p:grpSp>
     </p:spTree>
     <p:extLst>
@@ -27324,7 +27563,7 @@
               <a:rPr lang="en-US" sz="1700" dirty="0">
                 <a:latin typeface="+mj-lt"/>
               </a:rPr>
-              <a:t> and biases of every layer, optimizer, and hyperparameter). </a:t>
+              <a:t> and biases of every layer, optimizer, and hyperparameter)</a:t>
             </a:r>
           </a:p>
           <a:p>
@@ -27339,7 +27578,7 @@
               <a:rPr lang="en-US" sz="1700" dirty="0">
                 <a:latin typeface="+mj-lt"/>
               </a:rPr>
-              <a:t>You can later on load this model (maybe in a different computer) and make predictions. This is done with </a:t>
+              <a:t>You can load this model later on (maybe in a different computer) and make predictions. This is done with </a:t>
             </a:r>
             <a:r>
               <a:rPr lang="en-US" sz="1700" i="1" dirty="0" err="1">
@@ -27378,7 +27617,7 @@
               <a:rPr lang="en-US" sz="1700" dirty="0">
                 <a:latin typeface="+mj-lt"/>
               </a:rPr>
-              <a:t> at regular intervals. </a:t>
+              <a:t> at regular intervals </a:t>
             </a:r>
           </a:p>
           <a:p>
@@ -27405,7 +27644,7 @@
               <a:rPr lang="en-US" sz="1700" dirty="0">
                 <a:latin typeface="+mj-lt"/>
               </a:rPr>
-              <a:t> The default option saves the model at the end of each epoch (but it can be customized).</a:t>
+              <a:t> The default option saves the model at the end of each epoch (but it can be customized)</a:t>
             </a:r>
           </a:p>
           <a:p>
@@ -28069,7 +28308,7 @@
               <a:buChar char="§"/>
             </a:pPr>
             <a:r>
-              <a:rPr lang="en-US" sz="2200" dirty="0">
+              <a:rPr lang="en-US" sz="2000" dirty="0">
                 <a:latin typeface="+mj-lt"/>
                 <a:cs typeface="Times New Roman" panose="02020603050405020304" pitchFamily="18" charset="0"/>
               </a:rPr>
@@ -28085,11 +28324,11 @@
               <a:buChar char="§"/>
             </a:pPr>
             <a:r>
-              <a:rPr lang="en-US" sz="2200" dirty="0">
+              <a:rPr lang="en-US" sz="2000" dirty="0">
                 <a:latin typeface="+mj-lt"/>
                 <a:cs typeface="Times New Roman" panose="02020603050405020304" pitchFamily="18" charset="0"/>
               </a:rPr>
-              <a:t>One options is try many combinations of hyperparameters, either using grid or random search. However, we can end up with hundreds o model, each of them needing ours to be trained</a:t>
+              <a:t>One options is try many combinations of hyperparameters, either using grid or random search. However, we can end up with hundreds of models, each of them needing hours to be trained</a:t>
             </a:r>
           </a:p>
           <a:p>
@@ -28101,7 +28340,7 @@
               <a:buChar char="§"/>
             </a:pPr>
             <a:r>
-              <a:rPr lang="en-US" sz="2200" dirty="0">
+              <a:rPr lang="en-US" sz="2000" dirty="0">
                 <a:latin typeface="+mj-lt"/>
                 <a:cs typeface="Times New Roman" panose="02020603050405020304" pitchFamily="18" charset="0"/>
               </a:rPr>
@@ -28117,13 +28356,13 @@
               <a:buChar char="§"/>
             </a:pPr>
             <a:r>
-              <a:rPr lang="en-US" sz="1800" dirty="0" err="1">
+              <a:rPr lang="en-US" sz="1600" dirty="0" err="1">
                 <a:latin typeface="+mj-lt"/>
                 <a:cs typeface="Times New Roman" panose="02020603050405020304" pitchFamily="18" charset="0"/>
               </a:rPr>
               <a:t>Hyperopt</a:t>
             </a:r>
-            <a:endParaRPr lang="en-US" sz="1800" dirty="0">
+            <a:endParaRPr lang="en-US" sz="1600" dirty="0">
               <a:latin typeface="+mj-lt"/>
               <a:cs typeface="Times New Roman" panose="02020603050405020304" pitchFamily="18" charset="0"/>
             </a:endParaRPr>
@@ -28137,13 +28376,13 @@
               <a:buChar char="§"/>
             </a:pPr>
             <a:r>
-              <a:rPr lang="en-US" sz="1800" dirty="0" err="1">
+              <a:rPr lang="en-US" sz="1600" dirty="0" err="1">
                 <a:latin typeface="+mj-lt"/>
                 <a:cs typeface="Times New Roman" panose="02020603050405020304" pitchFamily="18" charset="0"/>
               </a:rPr>
               <a:t>Hyperas</a:t>
             </a:r>
-            <a:endParaRPr lang="en-US" sz="1800" dirty="0">
+            <a:endParaRPr lang="en-US" sz="1600" dirty="0">
               <a:latin typeface="+mj-lt"/>
               <a:cs typeface="Times New Roman" panose="02020603050405020304" pitchFamily="18" charset="0"/>
             </a:endParaRPr>
@@ -28157,14 +28396,14 @@
               <a:buChar char="§"/>
             </a:pPr>
             <a:r>
-              <a:rPr lang="en-US" sz="1800" dirty="0" err="1">
+              <a:rPr lang="en-US" sz="1600" dirty="0" err="1">
                 <a:latin typeface="+mj-lt"/>
                 <a:cs typeface="Times New Roman" panose="02020603050405020304" pitchFamily="18" charset="0"/>
               </a:rPr>
               <a:t>Keras</a:t>
             </a:r>
             <a:r>
-              <a:rPr lang="en-US" sz="1800" dirty="0">
+              <a:rPr lang="en-US" sz="1600" dirty="0">
                 <a:latin typeface="+mj-lt"/>
                 <a:cs typeface="Times New Roman" panose="02020603050405020304" pitchFamily="18" charset="0"/>
               </a:rPr>
@@ -28180,7 +28419,7 @@
               <a:buChar char="§"/>
             </a:pPr>
             <a:r>
-              <a:rPr lang="en-US" sz="1800" dirty="0">
+              <a:rPr lang="en-US" sz="1600" dirty="0">
                 <a:latin typeface="+mj-lt"/>
                 <a:cs typeface="Times New Roman" panose="02020603050405020304" pitchFamily="18" charset="0"/>
               </a:rPr>
@@ -28196,7 +28435,7 @@
               <a:buChar char="§"/>
             </a:pPr>
             <a:r>
-              <a:rPr lang="en-US" sz="1800" dirty="0">
+              <a:rPr lang="en-US" sz="1600" dirty="0">
                 <a:latin typeface="+mj-lt"/>
                 <a:cs typeface="Times New Roman" panose="02020603050405020304" pitchFamily="18" charset="0"/>
               </a:rPr>
@@ -28212,7 +28451,7 @@
               <a:buChar char="§"/>
             </a:pPr>
             <a:r>
-              <a:rPr lang="en-US" sz="1800" dirty="0">
+              <a:rPr lang="en-US" sz="1600" dirty="0">
                 <a:latin typeface="+mj-lt"/>
                 <a:cs typeface="Times New Roman" panose="02020603050405020304" pitchFamily="18" charset="0"/>
               </a:rPr>
@@ -28228,14 +28467,14 @@
               <a:buChar char="§"/>
             </a:pPr>
             <a:r>
-              <a:rPr lang="en-US" sz="1800" dirty="0" err="1">
+              <a:rPr lang="en-US" sz="1600" dirty="0" err="1">
                 <a:latin typeface="+mj-lt"/>
                 <a:cs typeface="Times New Roman" panose="02020603050405020304" pitchFamily="18" charset="0"/>
               </a:rPr>
               <a:t>Sklearn</a:t>
             </a:r>
             <a:r>
-              <a:rPr lang="en-US" sz="1800" dirty="0">
+              <a:rPr lang="en-US" sz="1600" dirty="0">
                 <a:latin typeface="+mj-lt"/>
                 <a:cs typeface="Times New Roman" panose="02020603050405020304" pitchFamily="18" charset="0"/>
               </a:rPr>
@@ -28250,7 +28489,7 @@
               <a:buFont typeface="Wingdings" panose="05000000000000000000" pitchFamily="2" charset="2"/>
               <a:buChar char="§"/>
             </a:pPr>
-            <a:endParaRPr lang="es-ES" sz="1500" dirty="0">
+            <a:endParaRPr lang="es-ES" sz="1400" dirty="0">
               <a:latin typeface="+mj-lt"/>
             </a:endParaRPr>
           </a:p>
@@ -28876,7 +29115,7 @@
               <a:buChar char="§"/>
             </a:pPr>
             <a:r>
-              <a:rPr lang="en-US" dirty="0">
+              <a:rPr lang="en-US" sz="2000" dirty="0">
                 <a:latin typeface="+mj-lt"/>
                 <a:cs typeface="Times New Roman" panose="02020603050405020304" pitchFamily="18" charset="0"/>
               </a:rPr>
@@ -28892,18 +29131,18 @@
               <a:buChar char="§"/>
             </a:pPr>
             <a:r>
-              <a:rPr lang="en-US" sz="1800" b="1" dirty="0">
+              <a:rPr lang="en-US" sz="1600" b="1" dirty="0">
                 <a:latin typeface="+mj-lt"/>
                 <a:cs typeface="Times New Roman" panose="02020603050405020304" pitchFamily="18" charset="0"/>
               </a:rPr>
               <a:t>Number of hidden layers: </a:t>
             </a:r>
             <a:r>
-              <a:rPr lang="en-US" sz="1800" dirty="0">
+              <a:rPr lang="en-US" sz="1600" dirty="0">
                 <a:latin typeface="+mj-lt"/>
                 <a:cs typeface="Times New Roman" panose="02020603050405020304" pitchFamily="18" charset="0"/>
               </a:rPr>
-              <a:t>For MANY problems, you can begin with one single layer and obtain reasonable results. However, for complex problems, deep networks have a much higher parameter efficiency than shallow ones. This is, more layers with fewer neurons better capture higher complexities that one layer with lots of neurons. You can start with one and ramp up until you identify overfitting.</a:t>
+              <a:t>For MOST problems, you can begin with one single layer and obtain reasonable results. However, for complex problems, deep networks have a much higher parameter efficiency than shallow ones. This is, more layers with fewer neurons better capture higher complexities that one layer with lots of neurons. You can start with one and ramp up until you identify overfitting.</a:t>
             </a:r>
           </a:p>
           <a:p>
@@ -28915,28 +29154,28 @@
               <a:buChar char="§"/>
             </a:pPr>
             <a:r>
-              <a:rPr lang="en-US" sz="1800" b="1" dirty="0">
+              <a:rPr lang="en-US" sz="1600" b="1" dirty="0">
                 <a:latin typeface="+mj-lt"/>
                 <a:cs typeface="Times New Roman" panose="02020603050405020304" pitchFamily="18" charset="0"/>
               </a:rPr>
               <a:t>Number of neurons per hidden layer:</a:t>
             </a:r>
             <a:r>
-              <a:rPr lang="en-US" sz="1800" dirty="0">
+              <a:rPr lang="en-US" sz="1600" dirty="0">
                 <a:latin typeface="+mj-lt"/>
                 <a:cs typeface="Times New Roman" panose="02020603050405020304" pitchFamily="18" charset="0"/>
               </a:rPr>
               <a:t> It was common to use a </a:t>
             </a:r>
             <a:r>
-              <a:rPr lang="en-US" sz="1800" i="1" dirty="0">
+              <a:rPr lang="en-US" sz="1600" i="1" dirty="0">
                 <a:latin typeface="+mj-lt"/>
                 <a:cs typeface="Times New Roman" panose="02020603050405020304" pitchFamily="18" charset="0"/>
               </a:rPr>
               <a:t>pyramidal </a:t>
             </a:r>
             <a:r>
-              <a:rPr lang="en-US" sz="1800" dirty="0">
+              <a:rPr lang="en-US" sz="1600" dirty="0">
                 <a:latin typeface="+mj-lt"/>
                 <a:cs typeface="Times New Roman" panose="02020603050405020304" pitchFamily="18" charset="0"/>
               </a:rPr>
@@ -30454,11 +30693,18 @@
               <a:buChar char="§"/>
             </a:pPr>
             <a:r>
+              <a:rPr lang="en-US" sz="1800" b="1" dirty="0">
+                <a:latin typeface="+mj-lt"/>
+                <a:cs typeface="Times New Roman" panose="02020603050405020304" pitchFamily="18" charset="0"/>
+              </a:rPr>
+              <a:t>Learning rate</a:t>
+            </a:r>
+            <a:r>
               <a:rPr lang="en-US" sz="1800" dirty="0">
                 <a:latin typeface="+mj-lt"/>
                 <a:cs typeface="Times New Roman" panose="02020603050405020304" pitchFamily="18" charset="0"/>
               </a:rPr>
-              <a:t>Learning rate: Probably the mot important hyperparameter. Train the NN for a few hundred iterations starting with a very low learning rate and gradually increase it up to a very large value. Plot the loss as a function of the learning rate and you will find the optimal value. You can then reinitiate  the model and train it again using that learning rate.</a:t>
+              <a:t>: Probably the mot important hyperparameter. Train the NN for a few hundred iterations starting with a very low learning rate and gradually increase it up to a very large value. Plot the loss as a function of the learning rate and you will find the optimal value. You can then reinitiate  the model and train it again using that learning rate.</a:t>
             </a:r>
           </a:p>
           <a:p>
@@ -30470,11 +30716,18 @@
               <a:buChar char="§"/>
             </a:pPr>
             <a:r>
+              <a:rPr lang="en-US" sz="1800" b="1" dirty="0">
+                <a:latin typeface="+mj-lt"/>
+                <a:cs typeface="Times New Roman" panose="02020603050405020304" pitchFamily="18" charset="0"/>
+              </a:rPr>
+              <a:t>Batch size:</a:t>
+            </a:r>
+            <a:r>
               <a:rPr lang="en-US" sz="1800" dirty="0">
                 <a:latin typeface="+mj-lt"/>
                 <a:cs typeface="Times New Roman" panose="02020603050405020304" pitchFamily="18" charset="0"/>
               </a:rPr>
-              <a:t>Batch size: Long story short, there is discussion about this, you can start with a large size and adjust progressively.</a:t>
+              <a:t> Long story short, there is discussion about this, you can start with a large size and adjust progressively.</a:t>
             </a:r>
           </a:p>
           <a:p>
@@ -30486,11 +30739,18 @@
               <a:buChar char="§"/>
             </a:pPr>
             <a:r>
+              <a:rPr lang="en-US" sz="1800" b="1" dirty="0">
+                <a:latin typeface="+mj-lt"/>
+                <a:cs typeface="Times New Roman" panose="02020603050405020304" pitchFamily="18" charset="0"/>
+              </a:rPr>
+              <a:t>Number of iterations:</a:t>
+            </a:r>
+            <a:r>
               <a:rPr lang="en-US" sz="1800" dirty="0">
                 <a:latin typeface="+mj-lt"/>
                 <a:cs typeface="Times New Roman" panose="02020603050405020304" pitchFamily="18" charset="0"/>
               </a:rPr>
-              <a:t>Number of iterations: No need to tweak this, use </a:t>
+              <a:t> No need to tweak this, use </a:t>
             </a:r>
             <a:r>
               <a:rPr lang="en-US" sz="1800" i="1" dirty="0">
@@ -30518,7 +30778,7 @@
                 <a:latin typeface="+mj-lt"/>
                 <a:cs typeface="Times New Roman" panose="02020603050405020304" pitchFamily="18" charset="0"/>
               </a:rPr>
-              <a:t> that makes the training stop when no improvement has been obtained in the last X number of epochs.</a:t>
+              <a:t> that makes the training to stop when no improvement has been obtained in the last X number of epochs.</a:t>
             </a:r>
           </a:p>
           <a:p>

</xml_diff>